<commit_message>
feat: citação final do Bob Marley (Liberte-se / Redemption Song)
Adiciona slide 42 com a citação emblemática de Bob Marley:
- 'Emancipate yourselves from mental slavery. None but ourselves
  can free our minds.' — Redemption Song (1980)
- Conecta com o tema central da apresentação: soberania
  tecnológica (5 camadas livres)
- Total: 44 slides

Atualiza:
- arreios-digitais-v2.md / -dark.md (fontes)
- .html / .pdf (light + dark)
- .pptx (light + dark)
</commit_message>
<xml_diff>
--- a/arreios-digitais-v2-dark.pptx
+++ b/arreios-digitais-v2-dark.pptx
@@ -48,6 +48,7 @@
     <p:sldId id="296" r:id="rId47"/>
     <p:sldId id="297" r:id="rId48"/>
     <p:sldId id="298" r:id="rId49"/>
+    <p:sldId id="299" r:id="rId50"/>
   </p:sldIdLst>
   <p:sldSz cx="12191695" cy="6858000" type="screen4x3"/>
   <p:notesSz cx="6858000" cy="9144000"/>
@@ -11043,7 +11044,7 @@
             <a:avLst/>
           </a:prstGeom>
           <a:solidFill>
-            <a:srgbClr val="1E1E2E"/>
+            <a:srgbClr val="11111B"/>
           </a:solidFill>
           <a:ln>
             <a:noFill/>
@@ -11079,8 +11080,8 @@
         </p:nvSpPr>
         <p:spPr>
           <a:xfrm>
-            <a:off x="274320" y="6537960"/>
-            <a:ext cx="11612880" cy="274320"/>
+            <a:off x="457200" y="548640"/>
+            <a:ext cx="11247120" cy="914400"/>
           </a:xfrm>
           <a:prstGeom prst="rect">
             <a:avLst/>
@@ -11094,12 +11095,12 @@
           <a:lstStyle/>
           <a:p>
             <a:r>
-              <a:rPr sz="1000" b="0" i="1">
-                <a:solidFill>
-                  <a:srgbClr val="6C7086"/>
-                </a:solidFill>
-              </a:rPr>
-              <a:t>Ney Lemke · UNESP · CTInf · 2026    ·    42</a:t>
+              <a:rPr sz="3200" b="1" i="0">
+                <a:solidFill>
+                  <a:srgbClr val="89B4FA"/>
+                </a:solidFill>
+              </a:rPr>
+              <a:t>Liberte-se</a:t>
             </a:r>
           </a:p>
         </p:txBody>
@@ -11112,8 +11113,8 @@
         </p:nvSpPr>
         <p:spPr>
           <a:xfrm>
-            <a:off x="457200" y="548640"/>
-            <a:ext cx="11247120" cy="914400"/>
+            <a:off x="457200" y="1554480"/>
+            <a:ext cx="11247120" cy="4846320"/>
           </a:xfrm>
           <a:prstGeom prst="rect">
             <a:avLst/>
@@ -11127,65 +11128,44 @@
           <a:lstStyle/>
           <a:p>
             <a:r>
-              <a:rPr sz="3200" b="1" i="0">
-                <a:solidFill>
-                  <a:srgbClr val="89B4FA"/>
-                </a:solidFill>
-              </a:rPr>
-              <a:t>Perguntas?</a:t>
-            </a:r>
-          </a:p>
-        </p:txBody>
-      </p:sp>
-      <p:sp>
-        <p:nvSpPr>
-          <p:cNvPr id="5" name="TextBox 4"/>
-          <p:cNvSpPr txBox="1"/>
-          <p:nvPr/>
-        </p:nvSpPr>
-        <p:spPr>
-          <a:xfrm>
-            <a:off x="457200" y="1554480"/>
-            <a:ext cx="11247120" cy="4846320"/>
-          </a:xfrm>
-          <a:prstGeom prst="rect">
-            <a:avLst/>
-          </a:prstGeom>
-          <a:noFill/>
-        </p:spPr>
-        <p:txBody>
-          <a:bodyPr wrap="square">
-            <a:spAutoFit/>
-          </a:bodyPr>
-          <a:lstStyle/>
-          <a:p>
-            <a:r>
-              <a:rPr sz="1400" b="0" i="0">
-                <a:solidFill>
-                  <a:srgbClr val="CDD6F4"/>
-                </a:solidFill>
-              </a:rPr>
-              <a:t>Ney Lemke</a:t>
-            </a:r>
-          </a:p>
-          <a:p>
-            <a:r>
-              <a:rPr sz="1400" b="0" i="0">
-                <a:solidFill>
-                  <a:srgbClr val="CDD6F4"/>
-                </a:solidFill>
-              </a:rPr>
-              <a:t>CIO · UNESP · CTInf</a:t>
-            </a:r>
-          </a:p>
-          <a:p>
-            <a:r>
-              <a:rPr sz="1400" b="0" i="0">
-                <a:solidFill>
-                  <a:srgbClr val="CDD6F4"/>
-                </a:solidFill>
-              </a:rPr>
-              <a:t>ney.lemke@unesp.br</a:t>
+              <a:rPr sz="1400" b="0" i="0">
+                <a:solidFill>
+                  <a:srgbClr val="CDD6F4"/>
+                </a:solidFill>
+              </a:rPr>
+              <a:t>&gt; "Emancipate yourselves from mental slavery.</a:t>
+            </a:r>
+          </a:p>
+          <a:p>
+            <a:r>
+              <a:rPr sz="1400" b="0" i="0">
+                <a:solidFill>
+                  <a:srgbClr val="CDD6F4"/>
+                </a:solidFill>
+              </a:rPr>
+              <a:t>&gt; None but ourselves can free our minds."</a:t>
+            </a:r>
+          </a:p>
+          <a:p/>
+          <a:p>
+            <a:r>
+              <a:rPr sz="1400" b="0" i="0">
+                <a:solidFill>
+                  <a:srgbClr val="CDD6F4"/>
+                </a:solidFill>
+              </a:rPr>
+              <a:t>*— Bob Marley, Redemption Song (1980)*</a:t>
+            </a:r>
+          </a:p>
+          <a:p/>
+          <a:p>
+            <a:r>
+              <a:rPr sz="1400" b="0" i="0">
+                <a:solidFill>
+                  <a:srgbClr val="CDD6F4"/>
+                </a:solidFill>
+              </a:rPr>
+              <a:t>A engenharia de IA tem a mesma forma: ninguém vai libertar seu workflow a não ser você mesmo. Cada camada que você controla (SO, LLM, arreio, apps, bots) é uma camada de soberania que nenhum fornecedor pode tirar de você.</a:t>
             </a:r>
           </a:p>
         </p:txBody>
@@ -11280,6 +11260,186 @@
                 </a:solidFill>
               </a:rPr>
               <a:t>Ney Lemke · UNESP · CTInf · 2026    ·    43</a:t>
+            </a:r>
+          </a:p>
+        </p:txBody>
+      </p:sp>
+      <p:sp>
+        <p:nvSpPr>
+          <p:cNvPr id="4" name="TextBox 3"/>
+          <p:cNvSpPr txBox="1"/>
+          <p:nvPr/>
+        </p:nvSpPr>
+        <p:spPr>
+          <a:xfrm>
+            <a:off x="457200" y="548640"/>
+            <a:ext cx="11247120" cy="914400"/>
+          </a:xfrm>
+          <a:prstGeom prst="rect">
+            <a:avLst/>
+          </a:prstGeom>
+          <a:noFill/>
+        </p:spPr>
+        <p:txBody>
+          <a:bodyPr wrap="square">
+            <a:spAutoFit/>
+          </a:bodyPr>
+          <a:lstStyle/>
+          <a:p>
+            <a:r>
+              <a:rPr sz="3200" b="1" i="0">
+                <a:solidFill>
+                  <a:srgbClr val="89B4FA"/>
+                </a:solidFill>
+              </a:rPr>
+              <a:t>Perguntas?</a:t>
+            </a:r>
+          </a:p>
+        </p:txBody>
+      </p:sp>
+      <p:sp>
+        <p:nvSpPr>
+          <p:cNvPr id="5" name="TextBox 4"/>
+          <p:cNvSpPr txBox="1"/>
+          <p:nvPr/>
+        </p:nvSpPr>
+        <p:spPr>
+          <a:xfrm>
+            <a:off x="457200" y="1554480"/>
+            <a:ext cx="11247120" cy="4846320"/>
+          </a:xfrm>
+          <a:prstGeom prst="rect">
+            <a:avLst/>
+          </a:prstGeom>
+          <a:noFill/>
+        </p:spPr>
+        <p:txBody>
+          <a:bodyPr wrap="square">
+            <a:spAutoFit/>
+          </a:bodyPr>
+          <a:lstStyle/>
+          <a:p>
+            <a:r>
+              <a:rPr sz="1400" b="0" i="0">
+                <a:solidFill>
+                  <a:srgbClr val="CDD6F4"/>
+                </a:solidFill>
+              </a:rPr>
+              <a:t>Ney Lemke</a:t>
+            </a:r>
+          </a:p>
+          <a:p>
+            <a:r>
+              <a:rPr sz="1400" b="0" i="0">
+                <a:solidFill>
+                  <a:srgbClr val="CDD6F4"/>
+                </a:solidFill>
+              </a:rPr>
+              <a:t>CIO · UNESP · CTInf</a:t>
+            </a:r>
+          </a:p>
+          <a:p>
+            <a:r>
+              <a:rPr sz="1400" b="0" i="0">
+                <a:solidFill>
+                  <a:srgbClr val="CDD6F4"/>
+                </a:solidFill>
+              </a:rPr>
+              <a:t>ney.lemke@unesp.br</a:t>
+            </a:r>
+          </a:p>
+        </p:txBody>
+      </p:sp>
+    </p:spTree>
+  </p:cSld>
+  <p:clrMapOvr>
+    <a:masterClrMapping/>
+  </p:clrMapOvr>
+</p:sld>
+</file>
+
+<file path=ppt/slides/slide44.xml><?xml version="1.0" encoding="utf-8"?>
+<p:sld xmlns:a="http://schemas.openxmlformats.org/drawingml/2006/main" xmlns:p="http://schemas.openxmlformats.org/presentationml/2006/main" xmlns:r="http://schemas.openxmlformats.org/officeDocument/2006/relationships">
+  <p:cSld>
+    <p:spTree>
+      <p:nvGrpSpPr>
+        <p:cNvPr id="1" name=""/>
+        <p:cNvGrpSpPr/>
+        <p:nvPr/>
+      </p:nvGrpSpPr>
+      <p:grpSpPr/>
+      <p:sp>
+        <p:nvSpPr>
+          <p:cNvPr id="2" name="Rectangle 1"/>
+          <p:cNvSpPr/>
+          <p:nvPr/>
+        </p:nvSpPr>
+        <p:spPr>
+          <a:xfrm>
+            <a:off x="0" y="0"/>
+            <a:ext cx="12191695" cy="6858000"/>
+          </a:xfrm>
+          <a:prstGeom prst="rect">
+            <a:avLst/>
+          </a:prstGeom>
+          <a:solidFill>
+            <a:srgbClr val="1E1E2E"/>
+          </a:solidFill>
+          <a:ln>
+            <a:noFill/>
+          </a:ln>
+        </p:spPr>
+        <p:style>
+          <a:lnRef idx="1">
+            <a:schemeClr val="accent1"/>
+          </a:lnRef>
+          <a:fillRef idx="3">
+            <a:schemeClr val="accent1"/>
+          </a:fillRef>
+          <a:effectRef idx="2">
+            <a:schemeClr val="accent1"/>
+          </a:effectRef>
+          <a:fontRef idx="minor">
+            <a:schemeClr val="lt1"/>
+          </a:fontRef>
+        </p:style>
+        <p:txBody>
+          <a:bodyPr rtlCol="0" anchor="ctr"/>
+          <a:lstStyle/>
+          <a:p>
+            <a:pPr algn="ctr"/>
+          </a:p>
+        </p:txBody>
+      </p:sp>
+      <p:sp>
+        <p:nvSpPr>
+          <p:cNvPr id="3" name="TextBox 2"/>
+          <p:cNvSpPr txBox="1"/>
+          <p:nvPr/>
+        </p:nvSpPr>
+        <p:spPr>
+          <a:xfrm>
+            <a:off x="274320" y="6537960"/>
+            <a:ext cx="11612880" cy="274320"/>
+          </a:xfrm>
+          <a:prstGeom prst="rect">
+            <a:avLst/>
+          </a:prstGeom>
+          <a:noFill/>
+        </p:spPr>
+        <p:txBody>
+          <a:bodyPr wrap="square">
+            <a:spAutoFit/>
+          </a:bodyPr>
+          <a:lstStyle/>
+          <a:p>
+            <a:r>
+              <a:rPr sz="1000" b="0" i="1">
+                <a:solidFill>
+                  <a:srgbClr val="6C7086"/>
+                </a:solidFill>
+              </a:rPr>
+              <a:t>Ney Lemke · UNESP · CTInf · 2026    ·    44</a:t>
             </a:r>
           </a:p>
         </p:txBody>

</xml_diff>